<commit_message>
Restyle promotion case slide to match website dark theme and add portfolio link
- Aligned banner colors with website palette (dark bg, teal accent, gold highlights)
- Updated all text colors for dark theme readability
- Added clickable hyperlink to jessiewang0926.github.io/Jessie-Capco-Journey
- All original promotional case content preserved as-is

https://claude.ai/code/session_019RPF8j4FKwWWZrkstQbaTn
</commit_message>
<xml_diff>
--- a/Jessie_Wang_Promotion_Case_v2.pptx
+++ b/Jessie_Wang_Promotion_Case_v2.pptx
@@ -3103,11 +3103,11 @@
             <a:avLst/>
           </a:prstGeom>
           <a:solidFill>
-            <a:srgbClr val="F8FAFC"/>
+            <a:srgbClr val="0A0A0F"/>
           </a:solidFill>
           <a:ln>
             <a:solidFill>
-              <a:srgbClr val="F8FAFC"/>
+              <a:srgbClr val="0A0A0F"/>
             </a:solidFill>
           </a:ln>
         </p:spPr>
@@ -3148,11 +3148,11 @@
             <a:avLst/>
           </a:prstGeom>
           <a:solidFill>
-            <a:srgbClr val="365F68"/>
+            <a:srgbClr val="0D1117"/>
           </a:solidFill>
           <a:ln>
             <a:solidFill>
-              <a:srgbClr val="365F68"/>
+              <a:srgbClr val="0D1117"/>
             </a:solidFill>
           </a:ln>
         </p:spPr>
@@ -3193,11 +3193,11 @@
             <a:avLst/>
           </a:prstGeom>
           <a:solidFill>
-            <a:srgbClr val="905318"/>
+            <a:srgbClr val="00BFA6"/>
           </a:solidFill>
           <a:ln>
             <a:solidFill>
-              <a:srgbClr val="905318"/>
+              <a:srgbClr val="00BFA6"/>
             </a:solidFill>
           </a:ln>
         </p:spPr>
@@ -3238,11 +3238,11 @@
             <a:avLst/>
           </a:prstGeom>
           <a:solidFill>
-            <a:srgbClr val="FFFFFF"/>
+            <a:srgbClr val="F0C040"/>
           </a:solidFill>
           <a:ln>
             <a:solidFill>
-              <a:srgbClr val="FFFFFF"/>
+              <a:srgbClr val="F0C040"/>
             </a:solidFill>
           </a:ln>
         </p:spPr>
@@ -3318,11 +3318,11 @@
             <a:avLst/>
           </a:prstGeom>
           <a:solidFill>
-            <a:srgbClr val="FFFFFF"/>
+            <a:srgbClr val="00BFA6"/>
           </a:solidFill>
           <a:ln>
             <a:solidFill>
-              <a:srgbClr val="FFFFFF"/>
+              <a:srgbClr val="00BFA6"/>
             </a:solidFill>
           </a:ln>
         </p:spPr>
@@ -3363,11 +3363,11 @@
             <a:avLst/>
           </a:prstGeom>
           <a:solidFill>
-            <a:srgbClr val="FFFFFF"/>
+            <a:srgbClr val="12141A"/>
           </a:solidFill>
           <a:ln>
             <a:solidFill>
-              <a:srgbClr val="D8DDE5"/>
+              <a:srgbClr val="1E222A"/>
             </a:solidFill>
           </a:ln>
         </p:spPr>
@@ -3419,7 +3419,7 @@
             <a:r>
               <a:rPr sz="1050" b="0">
                 <a:solidFill>
-                  <a:srgbClr val="1F2937"/>
+                  <a:srgbClr val="00BFA6"/>
                 </a:solidFill>
                 <a:latin typeface="Aptos"/>
               </a:rPr>
@@ -3454,7 +3454,7 @@
             <a:r>
               <a:rPr sz="1050" b="0">
                 <a:solidFill>
-                  <a:srgbClr val="415062"/>
+                  <a:srgbClr val="E8E8ED"/>
                 </a:solidFill>
                 <a:latin typeface="Aptos"/>
               </a:rPr>
@@ -3478,11 +3478,11 @@
             <a:avLst/>
           </a:prstGeom>
           <a:solidFill>
-            <a:srgbClr val="FFFFFF"/>
+            <a:srgbClr val="12141A"/>
           </a:solidFill>
           <a:ln>
             <a:solidFill>
-              <a:srgbClr val="D8DDE5"/>
+              <a:srgbClr val="1E222A"/>
             </a:solidFill>
           </a:ln>
         </p:spPr>
@@ -3534,7 +3534,7 @@
             <a:r>
               <a:rPr sz="1050" b="0">
                 <a:solidFill>
-                  <a:srgbClr val="1F2937"/>
+                  <a:srgbClr val="00BFA6"/>
                 </a:solidFill>
                 <a:latin typeface="Aptos"/>
               </a:rPr>
@@ -3569,7 +3569,7 @@
             <a:r>
               <a:rPr sz="1050" b="0">
                 <a:solidFill>
-                  <a:srgbClr val="415062"/>
+                  <a:srgbClr val="E8E8ED"/>
                 </a:solidFill>
                 <a:latin typeface="Aptos"/>
               </a:rPr>
@@ -3593,11 +3593,11 @@
             <a:avLst/>
           </a:prstGeom>
           <a:solidFill>
-            <a:srgbClr val="FFFFFF"/>
+            <a:srgbClr val="12141A"/>
           </a:solidFill>
           <a:ln>
             <a:solidFill>
-              <a:srgbClr val="D8DDE5"/>
+              <a:srgbClr val="1E222A"/>
             </a:solidFill>
           </a:ln>
         </p:spPr>
@@ -3649,7 +3649,7 @@
             <a:r>
               <a:rPr sz="1050" b="0">
                 <a:solidFill>
-                  <a:srgbClr val="1F2937"/>
+                  <a:srgbClr val="00BFA6"/>
                 </a:solidFill>
                 <a:latin typeface="Aptos"/>
               </a:rPr>
@@ -3684,7 +3684,7 @@
             <a:r>
               <a:rPr sz="1050" b="0">
                 <a:solidFill>
-                  <a:srgbClr val="415062"/>
+                  <a:srgbClr val="E8E8ED"/>
                 </a:solidFill>
                 <a:latin typeface="Aptos"/>
               </a:rPr>
@@ -3708,11 +3708,11 @@
             <a:avLst/>
           </a:prstGeom>
           <a:solidFill>
-            <a:srgbClr val="000000"/>
+            <a:srgbClr val="00BFA6"/>
           </a:solidFill>
           <a:ln>
             <a:solidFill>
-              <a:srgbClr val="000000"/>
+              <a:srgbClr val="00BFA6"/>
             </a:solidFill>
           </a:ln>
         </p:spPr>
@@ -3797,7 +3797,7 @@
             <a:r>
               <a:rPr sz="1050" b="0">
                 <a:solidFill>
-                  <a:srgbClr val="1F2937"/>
+                  <a:srgbClr val="E8E8ED"/>
                 </a:solidFill>
                 <a:latin typeface="Aptos"/>
               </a:rPr>
@@ -3832,7 +3832,7 @@
             <a:r>
               <a:rPr sz="1050" b="0">
                 <a:solidFill>
-                  <a:srgbClr val="415062"/>
+                  <a:srgbClr val="B0B0C0"/>
                 </a:solidFill>
                 <a:latin typeface="Aptos"/>
               </a:rPr>
@@ -3856,11 +3856,11 @@
             <a:avLst/>
           </a:prstGeom>
           <a:solidFill>
-            <a:srgbClr val="FFFFFF"/>
+            <a:srgbClr val="161B22"/>
           </a:solidFill>
           <a:ln>
             <a:solidFill>
-              <a:srgbClr val="D8DDE5"/>
+              <a:srgbClr val="2A2E36"/>
             </a:solidFill>
           </a:ln>
         </p:spPr>
@@ -3912,7 +3912,7 @@
             <a:r>
               <a:rPr sz="1050" b="0">
                 <a:solidFill>
-                  <a:srgbClr val="415062"/>
+                  <a:srgbClr val="B0B0C0"/>
                 </a:solidFill>
                 <a:latin typeface="Aptos"/>
               </a:rPr>
@@ -3936,11 +3936,11 @@
             <a:avLst/>
           </a:prstGeom>
           <a:solidFill>
-            <a:srgbClr val="FFFFFF"/>
+            <a:srgbClr val="161B22"/>
           </a:solidFill>
           <a:ln>
             <a:solidFill>
-              <a:srgbClr val="D8DDE5"/>
+              <a:srgbClr val="2A2E36"/>
             </a:solidFill>
           </a:ln>
         </p:spPr>
@@ -3992,7 +3992,7 @@
             <a:r>
               <a:rPr sz="1050" b="0">
                 <a:solidFill>
-                  <a:srgbClr val="415062"/>
+                  <a:srgbClr val="B0B0C0"/>
                 </a:solidFill>
                 <a:latin typeface="Aptos"/>
               </a:rPr>
@@ -4016,11 +4016,11 @@
             <a:avLst/>
           </a:prstGeom>
           <a:solidFill>
-            <a:srgbClr val="FFFFFF"/>
+            <a:srgbClr val="161B22"/>
           </a:solidFill>
           <a:ln>
             <a:solidFill>
-              <a:srgbClr val="D8DDE5"/>
+              <a:srgbClr val="2A2E36"/>
             </a:solidFill>
           </a:ln>
         </p:spPr>
@@ -4072,7 +4072,7 @@
             <a:r>
               <a:rPr sz="1050" b="0">
                 <a:solidFill>
-                  <a:srgbClr val="1F2937"/>
+                  <a:srgbClr val="E8E8ED"/>
                 </a:solidFill>
                 <a:latin typeface="Aptos"/>
               </a:rPr>
@@ -4107,7 +4107,7 @@
             <a:r>
               <a:rPr sz="850" b="0">
                 <a:solidFill>
-                  <a:srgbClr val="5F6F88"/>
+                  <a:srgbClr val="8B8B9E"/>
                 </a:solidFill>
                 <a:latin typeface="Aptos"/>
               </a:rPr>
@@ -4142,7 +4142,7 @@
             <a:r>
               <a:rPr sz="1050" b="0">
                 <a:solidFill>
-                  <a:srgbClr val="415062"/>
+                  <a:srgbClr val="B0B0C0"/>
                 </a:solidFill>
                 <a:latin typeface="Aptos"/>
               </a:rPr>
@@ -4166,11 +4166,11 @@
             <a:avLst/>
           </a:prstGeom>
           <a:solidFill>
-            <a:srgbClr val="FFFFFF"/>
+            <a:srgbClr val="161B22"/>
           </a:solidFill>
           <a:ln>
             <a:solidFill>
-              <a:srgbClr val="D8DDE5"/>
+              <a:srgbClr val="2A2E36"/>
             </a:solidFill>
           </a:ln>
         </p:spPr>
@@ -4222,7 +4222,7 @@
             <a:r>
               <a:rPr sz="1050" b="0">
                 <a:solidFill>
-                  <a:srgbClr val="415062"/>
+                  <a:srgbClr val="B0B0C0"/>
                 </a:solidFill>
                 <a:latin typeface="Aptos"/>
               </a:rPr>
@@ -4246,11 +4246,11 @@
             <a:avLst/>
           </a:prstGeom>
           <a:solidFill>
-            <a:srgbClr val="FFFFFF"/>
+            <a:srgbClr val="161B22"/>
           </a:solidFill>
           <a:ln>
             <a:solidFill>
-              <a:srgbClr val="D8DDE5"/>
+              <a:srgbClr val="2A2E36"/>
             </a:solidFill>
           </a:ln>
         </p:spPr>
@@ -4302,7 +4302,7 @@
             <a:r>
               <a:rPr sz="1050" b="0">
                 <a:solidFill>
-                  <a:srgbClr val="415062"/>
+                  <a:srgbClr val="B0B0C0"/>
                 </a:solidFill>
                 <a:latin typeface="Aptos"/>
               </a:rPr>
@@ -4326,11 +4326,11 @@
             <a:avLst/>
           </a:prstGeom>
           <a:solidFill>
-            <a:srgbClr val="FFFFFF"/>
+            <a:srgbClr val="161B22"/>
           </a:solidFill>
           <a:ln>
             <a:solidFill>
-              <a:srgbClr val="D8DDE5"/>
+              <a:srgbClr val="2A2E36"/>
             </a:solidFill>
           </a:ln>
         </p:spPr>
@@ -4371,11 +4371,11 @@
             <a:avLst/>
           </a:prstGeom>
           <a:solidFill>
-            <a:srgbClr val="15B3BE"/>
+            <a:srgbClr val="00BFA6"/>
           </a:solidFill>
           <a:ln>
             <a:solidFill>
-              <a:srgbClr val="15B3BE"/>
+              <a:srgbClr val="00BFA6"/>
             </a:solidFill>
           </a:ln>
         </p:spPr>
@@ -4451,11 +4451,11 @@
             <a:avLst/>
           </a:prstGeom>
           <a:solidFill>
-            <a:srgbClr val="0F6770"/>
+            <a:srgbClr val="0A8070"/>
           </a:solidFill>
           <a:ln>
             <a:solidFill>
-              <a:srgbClr val="0F6770"/>
+              <a:srgbClr val="0A8070"/>
             </a:solidFill>
           </a:ln>
         </p:spPr>
@@ -4531,11 +4531,11 @@
             <a:avLst/>
           </a:prstGeom>
           <a:solidFill>
-            <a:srgbClr val="FFC43A"/>
+            <a:srgbClr val="F0C040"/>
           </a:solidFill>
           <a:ln>
             <a:solidFill>
-              <a:srgbClr val="FFC43A"/>
+              <a:srgbClr val="F0C040"/>
             </a:solidFill>
           </a:ln>
         </p:spPr>
@@ -4611,11 +4611,11 @@
             <a:avLst/>
           </a:prstGeom>
           <a:solidFill>
-            <a:srgbClr val="000000"/>
+            <a:srgbClr val="1A1A2E"/>
           </a:solidFill>
           <a:ln>
             <a:solidFill>
-              <a:srgbClr val="000000"/>
+              <a:srgbClr val="1A1A2E"/>
             </a:solidFill>
           </a:ln>
         </p:spPr>
@@ -4691,11 +4691,11 @@
             <a:avLst/>
           </a:prstGeom>
           <a:solidFill>
-            <a:srgbClr val="D7F1F3"/>
+            <a:srgbClr val="101218"/>
           </a:solidFill>
           <a:ln>
             <a:solidFill>
-              <a:srgbClr val="DCE6EA"/>
+              <a:srgbClr val="1E222A"/>
             </a:solidFill>
           </a:ln>
         </p:spPr>
@@ -4736,11 +4736,11 @@
             <a:avLst/>
           </a:prstGeom>
           <a:solidFill>
-            <a:srgbClr val="EEF8F9"/>
+            <a:srgbClr val="0E1016"/>
           </a:solidFill>
           <a:ln>
             <a:solidFill>
-              <a:srgbClr val="DCE6EA"/>
+              <a:srgbClr val="1E222A"/>
             </a:solidFill>
           </a:ln>
         </p:spPr>
@@ -4781,11 +4781,11 @@
             <a:avLst/>
           </a:prstGeom>
           <a:solidFill>
-            <a:srgbClr val="FFF0C7"/>
+            <a:srgbClr val="14130E"/>
           </a:solidFill>
           <a:ln>
             <a:solidFill>
-              <a:srgbClr val="ECE1B7"/>
+              <a:srgbClr val="2A281E"/>
             </a:solidFill>
           </a:ln>
         </p:spPr>
@@ -4826,11 +4826,11 @@
             <a:avLst/>
           </a:prstGeom>
           <a:solidFill>
-            <a:srgbClr val="FFFFFF"/>
+            <a:srgbClr val="12141A"/>
           </a:solidFill>
           <a:ln>
             <a:solidFill>
-              <a:srgbClr val="D8DDE5"/>
+              <a:srgbClr val="1E222A"/>
             </a:solidFill>
           </a:ln>
         </p:spPr>
@@ -4882,7 +4882,7 @@
             <a:r>
               <a:rPr sz="1500" b="1">
                 <a:solidFill>
-                  <a:srgbClr val="1F2937"/>
+                  <a:srgbClr val="E8E8ED"/>
                 </a:solidFill>
                 <a:latin typeface="Aptos"/>
               </a:rPr>
@@ -4917,7 +4917,7 @@
             <a:r>
               <a:rPr sz="1060" b="0">
                 <a:solidFill>
-                  <a:srgbClr val="415062"/>
+                  <a:srgbClr val="B0B0C0"/>
                 </a:solidFill>
                 <a:latin typeface="Aptos"/>
               </a:rPr>
@@ -4952,7 +4952,7 @@
             <a:r>
               <a:rPr sz="1220" b="1">
                 <a:solidFill>
-                  <a:srgbClr val="1F2937"/>
+                  <a:srgbClr val="E8E8ED"/>
                 </a:solidFill>
                 <a:latin typeface="Aptos"/>
               </a:rPr>
@@ -4995,6 +4995,11 @@
               </a:defRPr>
             </a:pPr>
             <a:r>
+              <a:rPr>
+                <a:solidFill>
+                  <a:srgbClr val="B0B0C0"/>
+                </a:solidFill>
+              </a:rPr>
               <a:t>JefAI Product Lead: took ownership of product leadership for Jefferies' AI platform after my initial engagement was extended into a full-year contract, demonstrating trusted client ownership beyond an intake/proof-of-concept role.</a:t>
             </a:r>
           </a:p>
@@ -5011,6 +5016,11 @@
               </a:defRPr>
             </a:pPr>
             <a:r>
+              <a:rPr>
+                <a:solidFill>
+                  <a:srgbClr val="B0B0C0"/>
+                </a:solidFill>
+              </a:rPr>
               <a:t>Roadmap and governance: created Jefferies' first AI product roadmap and designed the JefAI programme dashboard to give stakeholders visibility into roadmap progress, risks, status and KPIs.</a:t>
             </a:r>
           </a:p>
@@ -5027,6 +5037,11 @@
               </a:defRPr>
             </a:pPr>
             <a:r>
+              <a:rPr>
+                <a:solidFill>
+                  <a:srgbClr val="B0B0C0"/>
+                </a:solidFill>
+              </a:rPr>
               <a:t>Operating at scale: manage product across an engineering organisation of approximately 26 people and coordinate with MP/ED/C-level stakeholders on priorities, delivery sequencing and platform evolution.</a:t>
             </a:r>
           </a:p>
@@ -5043,6 +5058,11 @@
               </a:defRPr>
             </a:pPr>
             <a:r>
+              <a:rPr>
+                <a:solidFill>
+                  <a:srgbClr val="B0B0C0"/>
+                </a:solidFill>
+              </a:rPr>
               <a:t>Programme leadership: helped move Jefferies from fragmented AI intake activity into a more structured, sustained product programme with repeatable roadmap execution and clear stakeholder alignment.</a:t>
             </a:r>
           </a:p>
@@ -5059,6 +5079,11 @@
               </a:defRPr>
             </a:pPr>
             <a:r>
+              <a:rPr>
+                <a:solidFill>
+                  <a:srgbClr val="B0B0C0"/>
+                </a:solidFill>
+              </a:rPr>
               <a:t>Leadership trajectory: the next step is to become the AI lead across the broader Jefferies AI programme, overseeing multiple AI workstreams given that I have helped build this from the ground up, work directly with C-level stakeholders and built strong relationships across divisions.</a:t>
             </a:r>
           </a:p>
@@ -5075,6 +5100,11 @@
               </a:defRPr>
             </a:pPr>
             <a:r>
+              <a:rPr>
+                <a:solidFill>
+                  <a:srgbClr val="B0B0C0"/>
+                </a:solidFill>
+              </a:rPr>
               <a:t>Trusted delivery leadership: acted as the pointed deputy for an MP-level AI programme delivery lead and helped run the team through roadmap communication, stakeholder coordination and delivery structure.</a:t>
             </a:r>
           </a:p>
@@ -5091,6 +5121,11 @@
               </a:defRPr>
             </a:pPr>
             <a:r>
+              <a:rPr>
+                <a:solidFill>
+                  <a:srgbClr val="B0B0C0"/>
+                </a:solidFill>
+              </a:rPr>
               <a:t>Executive visibility: became a regular speaker on the Jefferies AI Ambassadors call, presenting new solutions and sharing AI insight with a broader business audience.</a:t>
             </a:r>
           </a:p>
@@ -5122,7 +5157,7 @@
             <a:r>
               <a:rPr sz="1220" b="1">
                 <a:solidFill>
-                  <a:srgbClr val="1F2937"/>
+                  <a:srgbClr val="E8E8ED"/>
                 </a:solidFill>
                 <a:latin typeface="Aptos"/>
               </a:rPr>
@@ -5165,6 +5200,11 @@
               </a:defRPr>
             </a:pPr>
             <a:r>
+              <a:rPr>
+                <a:solidFill>
+                  <a:srgbClr val="B0B0C0"/>
+                </a:solidFill>
+              </a:rPr>
               <a:t>I have learned how to operate as both product owner and programme lead in a complex client environment, balancing senior stakeholder management, execution discipline and roadmap design.</a:t>
             </a:r>
           </a:p>
@@ -5181,6 +5221,11 @@
               </a:defRPr>
             </a:pPr>
             <a:r>
+              <a:rPr>
+                <a:solidFill>
+                  <a:srgbClr val="B0B0C0"/>
+                </a:solidFill>
+              </a:rPr>
               <a:t>At the next level, I would continue expanding JefAI from a roadmap-led platform into a broader enterprise AI product ecosystem, scaling adoption, solution maturity and commercial value for both Jefferies and Capco.</a:t>
             </a:r>
           </a:p>
@@ -5212,7 +5257,7 @@
             <a:r>
               <a:rPr sz="1400" b="1">
                 <a:solidFill>
-                  <a:srgbClr val="1F2937"/>
+                  <a:srgbClr val="E8E8ED"/>
                 </a:solidFill>
                 <a:latin typeface="Aptos"/>
               </a:rPr>
@@ -5255,6 +5300,11 @@
               </a:defRPr>
             </a:pPr>
             <a:r>
+              <a:rPr>
+                <a:solidFill>
+                  <a:srgbClr val="B0B0C0"/>
+                </a:solidFill>
+              </a:rPr>
               <a:t>I helped convert my Jefferies work from an initial AI intake/proof phase into a year-long product engagement, directly supporting continued revenue on the account.</a:t>
             </a:r>
           </a:p>
@@ -5271,6 +5321,11 @@
               </a:defRPr>
             </a:pPr>
             <a:r>
+              <a:rPr>
+                <a:solidFill>
+                  <a:srgbClr val="B0B0C0"/>
+                </a:solidFill>
+              </a:rPr>
               <a:t>By leading the JefAI roadmap and enterprise product direction, I am helping create scope for additional AI platform work and future solution expansion at Jefferies.</a:t>
             </a:r>
           </a:p>
@@ -5287,6 +5342,11 @@
               </a:defRPr>
             </a:pPr>
             <a:r>
+              <a:rPr>
+                <a:solidFill>
+                  <a:srgbClr val="B0B0C0"/>
+                </a:solidFill>
+              </a:rPr>
               <a:t>I contribute commercially by turning AI demos, product assets and market-facing storytelling into materials that can support pursuits, stakeholder buy-in and downstream sales opportunities.</a:t>
             </a:r>
           </a:p>
@@ -5303,6 +5363,11 @@
               </a:defRPr>
             </a:pPr>
             <a:r>
+              <a:rPr>
+                <a:solidFill>
+                  <a:srgbClr val="B0B0C0"/>
+                </a:solidFill>
+              </a:rPr>
               <a:t>External speaking and thought leadership increase Capco's visibility in GenAI and can help generate future client conversations, brand credibility and pipeline opportunities.</a:t>
             </a:r>
           </a:p>
@@ -5334,7 +5399,7 @@
             <a:r>
               <a:rPr sz="1030" b="0">
                 <a:solidFill>
-                  <a:srgbClr val="415062"/>
+                  <a:srgbClr val="B0B0C0"/>
                 </a:solidFill>
                 <a:latin typeface="Aptos"/>
               </a:rPr>
@@ -5369,7 +5434,7 @@
             <a:r>
               <a:rPr sz="1250" b="1">
                 <a:solidFill>
-                  <a:srgbClr val="1F2937"/>
+                  <a:srgbClr val="E8E8ED"/>
                 </a:solidFill>
                 <a:latin typeface="Aptos"/>
               </a:rPr>
@@ -5404,7 +5469,7 @@
             <a:r>
               <a:rPr sz="990" b="0">
                 <a:solidFill>
-                  <a:srgbClr val="415062"/>
+                  <a:srgbClr val="B0B0C0"/>
                 </a:solidFill>
                 <a:latin typeface="Aptos"/>
               </a:rPr>
@@ -5440,7 +5505,7 @@
             <a:r>
               <a:rPr sz="1050" b="0">
                 <a:solidFill>
-                  <a:srgbClr val="1F2937"/>
+                  <a:srgbClr val="B0B0C0"/>
                 </a:solidFill>
                 <a:latin typeface="Aptos"/>
               </a:rPr>
@@ -5464,11 +5529,11 @@
             <a:avLst/>
           </a:prstGeom>
           <a:solidFill>
-            <a:srgbClr val="FFFFFF"/>
+            <a:srgbClr val="161B22"/>
           </a:solidFill>
           <a:ln>
             <a:solidFill>
-              <a:srgbClr val="D8DDE5"/>
+              <a:srgbClr val="2A2E36"/>
             </a:solidFill>
           </a:ln>
         </p:spPr>
@@ -5520,7 +5585,7 @@
             <a:r>
               <a:rPr sz="1050" b="0">
                 <a:solidFill>
-                  <a:srgbClr val="1F2937"/>
+                  <a:srgbClr val="B0B0C0"/>
                 </a:solidFill>
                 <a:latin typeface="Aptos"/>
               </a:rPr>
@@ -5544,11 +5609,11 @@
             <a:avLst/>
           </a:prstGeom>
           <a:solidFill>
-            <a:srgbClr val="FFFFFF"/>
+            <a:srgbClr val="161B22"/>
           </a:solidFill>
           <a:ln>
             <a:solidFill>
-              <a:srgbClr val="D8DDE5"/>
+              <a:srgbClr val="2A2E36"/>
             </a:solidFill>
           </a:ln>
         </p:spPr>
@@ -5600,7 +5665,7 @@
             <a:r>
               <a:rPr sz="1050" b="0">
                 <a:solidFill>
-                  <a:srgbClr val="1F2937"/>
+                  <a:srgbClr val="B0B0C0"/>
                 </a:solidFill>
                 <a:latin typeface="Aptos"/>
               </a:rPr>
@@ -5624,11 +5689,11 @@
             <a:avLst/>
           </a:prstGeom>
           <a:solidFill>
-            <a:srgbClr val="FFFFFF"/>
+            <a:srgbClr val="161B22"/>
           </a:solidFill>
           <a:ln>
             <a:solidFill>
-              <a:srgbClr val="D8DDE5"/>
+              <a:srgbClr val="2A2E36"/>
             </a:solidFill>
           </a:ln>
         </p:spPr>
@@ -5680,7 +5745,7 @@
             <a:r>
               <a:rPr sz="1050" b="0">
                 <a:solidFill>
-                  <a:srgbClr val="1F2937"/>
+                  <a:srgbClr val="B0B0C0"/>
                 </a:solidFill>
                 <a:latin typeface="Aptos"/>
               </a:rPr>
@@ -5704,11 +5769,11 @@
             <a:avLst/>
           </a:prstGeom>
           <a:solidFill>
-            <a:srgbClr val="FFFFFF"/>
+            <a:srgbClr val="161B22"/>
           </a:solidFill>
           <a:ln>
             <a:solidFill>
-              <a:srgbClr val="D8DDE5"/>
+              <a:srgbClr val="2A2E36"/>
             </a:solidFill>
           </a:ln>
         </p:spPr>
@@ -5760,7 +5825,7 @@
             <a:r>
               <a:rPr sz="1050" b="0">
                 <a:solidFill>
-                  <a:srgbClr val="1F2937"/>
+                  <a:srgbClr val="B0B0C0"/>
                 </a:solidFill>
                 <a:latin typeface="Aptos"/>
               </a:rPr>
@@ -5784,11 +5849,11 @@
             <a:avLst/>
           </a:prstGeom>
           <a:solidFill>
-            <a:srgbClr val="FFFFFF"/>
+            <a:srgbClr val="161B22"/>
           </a:solidFill>
           <a:ln>
             <a:solidFill>
-              <a:srgbClr val="D8DDE5"/>
+              <a:srgbClr val="2A2E36"/>
             </a:solidFill>
           </a:ln>
         </p:spPr>
@@ -5840,7 +5905,7 @@
             <a:r>
               <a:rPr sz="1050" b="0">
                 <a:solidFill>
-                  <a:srgbClr val="1F2937"/>
+                  <a:srgbClr val="B0B0C0"/>
                 </a:solidFill>
                 <a:latin typeface="Aptos"/>
               </a:rPr>
@@ -5864,11 +5929,11 @@
             <a:avLst/>
           </a:prstGeom>
           <a:solidFill>
-            <a:srgbClr val="FFFFFF"/>
+            <a:srgbClr val="161B22"/>
           </a:solidFill>
           <a:ln>
             <a:solidFill>
-              <a:srgbClr val="D8DDE5"/>
+              <a:srgbClr val="2A2E36"/>
             </a:solidFill>
           </a:ln>
         </p:spPr>
@@ -5920,7 +5985,7 @@
             <a:r>
               <a:rPr sz="780" b="0">
                 <a:solidFill>
-                  <a:srgbClr val="9CA3AF"/>
+                  <a:srgbClr val="5A5A6E"/>
                 </a:solidFill>
                 <a:latin typeface="Aptos"/>
               </a:rPr>
@@ -5955,11 +6020,53 @@
             <a:r>
               <a:rPr sz="1000" b="0">
                 <a:solidFill>
-                  <a:srgbClr val="9CA3AF"/>
+                  <a:srgbClr val="5A5A6E"/>
                 </a:solidFill>
                 <a:latin typeface="Aptos"/>
               </a:rPr>
               <a:t>5</a:t>
+            </a:r>
+          </a:p>
+        </p:txBody>
+      </p:sp>
+      <p:sp>
+        <p:nvSpPr>
+          <p:cNvPr id="71" name="TextBox 70"/>
+          <p:cNvSpPr txBox="1"/>
+          <p:nvPr/>
+        </p:nvSpPr>
+        <p:spPr>
+          <a:xfrm>
+            <a:off x="585216" y="6300000"/>
+            <a:ext cx="6000000" cy="180000"/>
+          </a:xfrm>
+          <a:prstGeom prst="rect">
+            <a:avLst/>
+          </a:prstGeom>
+          <a:noFill/>
+        </p:spPr>
+        <p:txBody>
+          <a:bodyPr wrap="none">
+            <a:spAutoFit/>
+          </a:bodyPr>
+          <a:lstStyle/>
+          <a:p>
+            <a:r>
+              <a:rPr sz="900">
+                <a:solidFill>
+                  <a:srgbClr val="8B8B9E"/>
+                </a:solidFill>
+              </a:rPr>
+              <a:t>View full interactive portfolio →  </a:t>
+            </a:r>
+            <a:r>
+              <a:rPr sz="900" u="sng">
+                <a:solidFill>
+                  <a:srgbClr val="00BFA6"/>
+                </a:solidFill>
+                <a:hlinkClick r:id="rId2"/>
+              </a:rPr>
+              <a:t>jessiewang0926.github.io/Jessie-Capco-Journey</a:t>
             </a:r>
           </a:p>
         </p:txBody>

</xml_diff>

<commit_message>
Restyle only top banner to match website theme and add portfolio hyperlink
- Banner bar: dark background (#0d1117)
- Chevron: website teal (#00bfa6)
- Accent bar: website gold (#f0c040)
- Divider: teal accent
- Added clickable link to portfolio website at bottom
- All slide content and styling below the banner left completely untouched

https://claude.ai/code/session_019RPF8j4FKwWWZrkstQbaTn
</commit_message>
<xml_diff>
--- a/Jessie_Wang_Promotion_Case_v2.pptx
+++ b/Jessie_Wang_Promotion_Case_v2.pptx
@@ -3103,11 +3103,11 @@
             <a:avLst/>
           </a:prstGeom>
           <a:solidFill>
-            <a:srgbClr val="0A0A0F"/>
+            <a:srgbClr val="F8FAFC"/>
           </a:solidFill>
           <a:ln>
             <a:solidFill>
-              <a:srgbClr val="0A0A0F"/>
+              <a:srgbClr val="F8FAFC"/>
             </a:solidFill>
           </a:ln>
         </p:spPr>
@@ -3363,11 +3363,11 @@
             <a:avLst/>
           </a:prstGeom>
           <a:solidFill>
-            <a:srgbClr val="12141A"/>
+            <a:srgbClr val="FFFFFF"/>
           </a:solidFill>
           <a:ln>
             <a:solidFill>
-              <a:srgbClr val="1E222A"/>
+              <a:srgbClr val="D8DDE5"/>
             </a:solidFill>
           </a:ln>
         </p:spPr>
@@ -3419,7 +3419,7 @@
             <a:r>
               <a:rPr sz="1050" b="0">
                 <a:solidFill>
-                  <a:srgbClr val="00BFA6"/>
+                  <a:srgbClr val="1F2937"/>
                 </a:solidFill>
                 <a:latin typeface="Aptos"/>
               </a:rPr>
@@ -3454,7 +3454,7 @@
             <a:r>
               <a:rPr sz="1050" b="0">
                 <a:solidFill>
-                  <a:srgbClr val="E8E8ED"/>
+                  <a:srgbClr val="415062"/>
                 </a:solidFill>
                 <a:latin typeface="Aptos"/>
               </a:rPr>
@@ -3478,11 +3478,11 @@
             <a:avLst/>
           </a:prstGeom>
           <a:solidFill>
-            <a:srgbClr val="12141A"/>
+            <a:srgbClr val="FFFFFF"/>
           </a:solidFill>
           <a:ln>
             <a:solidFill>
-              <a:srgbClr val="1E222A"/>
+              <a:srgbClr val="D8DDE5"/>
             </a:solidFill>
           </a:ln>
         </p:spPr>
@@ -3534,7 +3534,7 @@
             <a:r>
               <a:rPr sz="1050" b="0">
                 <a:solidFill>
-                  <a:srgbClr val="00BFA6"/>
+                  <a:srgbClr val="1F2937"/>
                 </a:solidFill>
                 <a:latin typeface="Aptos"/>
               </a:rPr>
@@ -3569,7 +3569,7 @@
             <a:r>
               <a:rPr sz="1050" b="0">
                 <a:solidFill>
-                  <a:srgbClr val="E8E8ED"/>
+                  <a:srgbClr val="415062"/>
                 </a:solidFill>
                 <a:latin typeface="Aptos"/>
               </a:rPr>
@@ -3593,11 +3593,11 @@
             <a:avLst/>
           </a:prstGeom>
           <a:solidFill>
-            <a:srgbClr val="12141A"/>
+            <a:srgbClr val="FFFFFF"/>
           </a:solidFill>
           <a:ln>
             <a:solidFill>
-              <a:srgbClr val="1E222A"/>
+              <a:srgbClr val="D8DDE5"/>
             </a:solidFill>
           </a:ln>
         </p:spPr>
@@ -3649,7 +3649,7 @@
             <a:r>
               <a:rPr sz="1050" b="0">
                 <a:solidFill>
-                  <a:srgbClr val="00BFA6"/>
+                  <a:srgbClr val="1F2937"/>
                 </a:solidFill>
                 <a:latin typeface="Aptos"/>
               </a:rPr>
@@ -3684,7 +3684,7 @@
             <a:r>
               <a:rPr sz="1050" b="0">
                 <a:solidFill>
-                  <a:srgbClr val="E8E8ED"/>
+                  <a:srgbClr val="415062"/>
                 </a:solidFill>
                 <a:latin typeface="Aptos"/>
               </a:rPr>
@@ -3708,11 +3708,11 @@
             <a:avLst/>
           </a:prstGeom>
           <a:solidFill>
-            <a:srgbClr val="00BFA6"/>
+            <a:srgbClr val="000000"/>
           </a:solidFill>
           <a:ln>
             <a:solidFill>
-              <a:srgbClr val="00BFA6"/>
+              <a:srgbClr val="000000"/>
             </a:solidFill>
           </a:ln>
         </p:spPr>
@@ -3797,7 +3797,7 @@
             <a:r>
               <a:rPr sz="1050" b="0">
                 <a:solidFill>
-                  <a:srgbClr val="E8E8ED"/>
+                  <a:srgbClr val="1F2937"/>
                 </a:solidFill>
                 <a:latin typeface="Aptos"/>
               </a:rPr>
@@ -3832,7 +3832,7 @@
             <a:r>
               <a:rPr sz="1050" b="0">
                 <a:solidFill>
-                  <a:srgbClr val="B0B0C0"/>
+                  <a:srgbClr val="415062"/>
                 </a:solidFill>
                 <a:latin typeface="Aptos"/>
               </a:rPr>
@@ -3856,11 +3856,11 @@
             <a:avLst/>
           </a:prstGeom>
           <a:solidFill>
-            <a:srgbClr val="161B22"/>
+            <a:srgbClr val="FFFFFF"/>
           </a:solidFill>
           <a:ln>
             <a:solidFill>
-              <a:srgbClr val="2A2E36"/>
+              <a:srgbClr val="D8DDE5"/>
             </a:solidFill>
           </a:ln>
         </p:spPr>
@@ -3912,7 +3912,7 @@
             <a:r>
               <a:rPr sz="1050" b="0">
                 <a:solidFill>
-                  <a:srgbClr val="B0B0C0"/>
+                  <a:srgbClr val="415062"/>
                 </a:solidFill>
                 <a:latin typeface="Aptos"/>
               </a:rPr>
@@ -3936,11 +3936,11 @@
             <a:avLst/>
           </a:prstGeom>
           <a:solidFill>
-            <a:srgbClr val="161B22"/>
+            <a:srgbClr val="FFFFFF"/>
           </a:solidFill>
           <a:ln>
             <a:solidFill>
-              <a:srgbClr val="2A2E36"/>
+              <a:srgbClr val="D8DDE5"/>
             </a:solidFill>
           </a:ln>
         </p:spPr>
@@ -3992,7 +3992,7 @@
             <a:r>
               <a:rPr sz="1050" b="0">
                 <a:solidFill>
-                  <a:srgbClr val="B0B0C0"/>
+                  <a:srgbClr val="415062"/>
                 </a:solidFill>
                 <a:latin typeface="Aptos"/>
               </a:rPr>
@@ -4016,11 +4016,11 @@
             <a:avLst/>
           </a:prstGeom>
           <a:solidFill>
-            <a:srgbClr val="161B22"/>
+            <a:srgbClr val="FFFFFF"/>
           </a:solidFill>
           <a:ln>
             <a:solidFill>
-              <a:srgbClr val="2A2E36"/>
+              <a:srgbClr val="D8DDE5"/>
             </a:solidFill>
           </a:ln>
         </p:spPr>
@@ -4072,7 +4072,7 @@
             <a:r>
               <a:rPr sz="1050" b="0">
                 <a:solidFill>
-                  <a:srgbClr val="E8E8ED"/>
+                  <a:srgbClr val="1F2937"/>
                 </a:solidFill>
                 <a:latin typeface="Aptos"/>
               </a:rPr>
@@ -4107,7 +4107,7 @@
             <a:r>
               <a:rPr sz="850" b="0">
                 <a:solidFill>
-                  <a:srgbClr val="8B8B9E"/>
+                  <a:srgbClr val="5F6F88"/>
                 </a:solidFill>
                 <a:latin typeface="Aptos"/>
               </a:rPr>
@@ -4142,7 +4142,7 @@
             <a:r>
               <a:rPr sz="1050" b="0">
                 <a:solidFill>
-                  <a:srgbClr val="B0B0C0"/>
+                  <a:srgbClr val="415062"/>
                 </a:solidFill>
                 <a:latin typeface="Aptos"/>
               </a:rPr>
@@ -4166,11 +4166,11 @@
             <a:avLst/>
           </a:prstGeom>
           <a:solidFill>
-            <a:srgbClr val="161B22"/>
+            <a:srgbClr val="FFFFFF"/>
           </a:solidFill>
           <a:ln>
             <a:solidFill>
-              <a:srgbClr val="2A2E36"/>
+              <a:srgbClr val="D8DDE5"/>
             </a:solidFill>
           </a:ln>
         </p:spPr>
@@ -4222,7 +4222,7 @@
             <a:r>
               <a:rPr sz="1050" b="0">
                 <a:solidFill>
-                  <a:srgbClr val="B0B0C0"/>
+                  <a:srgbClr val="415062"/>
                 </a:solidFill>
                 <a:latin typeface="Aptos"/>
               </a:rPr>
@@ -4246,11 +4246,11 @@
             <a:avLst/>
           </a:prstGeom>
           <a:solidFill>
-            <a:srgbClr val="161B22"/>
+            <a:srgbClr val="FFFFFF"/>
           </a:solidFill>
           <a:ln>
             <a:solidFill>
-              <a:srgbClr val="2A2E36"/>
+              <a:srgbClr val="D8DDE5"/>
             </a:solidFill>
           </a:ln>
         </p:spPr>
@@ -4302,7 +4302,7 @@
             <a:r>
               <a:rPr sz="1050" b="0">
                 <a:solidFill>
-                  <a:srgbClr val="B0B0C0"/>
+                  <a:srgbClr val="415062"/>
                 </a:solidFill>
                 <a:latin typeface="Aptos"/>
               </a:rPr>
@@ -4326,11 +4326,11 @@
             <a:avLst/>
           </a:prstGeom>
           <a:solidFill>
-            <a:srgbClr val="161B22"/>
+            <a:srgbClr val="FFFFFF"/>
           </a:solidFill>
           <a:ln>
             <a:solidFill>
-              <a:srgbClr val="2A2E36"/>
+              <a:srgbClr val="D8DDE5"/>
             </a:solidFill>
           </a:ln>
         </p:spPr>
@@ -4371,11 +4371,11 @@
             <a:avLst/>
           </a:prstGeom>
           <a:solidFill>
-            <a:srgbClr val="00BFA6"/>
+            <a:srgbClr val="15B3BE"/>
           </a:solidFill>
           <a:ln>
             <a:solidFill>
-              <a:srgbClr val="00BFA6"/>
+              <a:srgbClr val="15B3BE"/>
             </a:solidFill>
           </a:ln>
         </p:spPr>
@@ -4451,11 +4451,11 @@
             <a:avLst/>
           </a:prstGeom>
           <a:solidFill>
-            <a:srgbClr val="0A8070"/>
+            <a:srgbClr val="0F6770"/>
           </a:solidFill>
           <a:ln>
             <a:solidFill>
-              <a:srgbClr val="0A8070"/>
+              <a:srgbClr val="0F6770"/>
             </a:solidFill>
           </a:ln>
         </p:spPr>
@@ -4531,11 +4531,11 @@
             <a:avLst/>
           </a:prstGeom>
           <a:solidFill>
-            <a:srgbClr val="F0C040"/>
+            <a:srgbClr val="FFC43A"/>
           </a:solidFill>
           <a:ln>
             <a:solidFill>
-              <a:srgbClr val="F0C040"/>
+              <a:srgbClr val="FFC43A"/>
             </a:solidFill>
           </a:ln>
         </p:spPr>
@@ -4611,11 +4611,11 @@
             <a:avLst/>
           </a:prstGeom>
           <a:solidFill>
-            <a:srgbClr val="1A1A2E"/>
+            <a:srgbClr val="000000"/>
           </a:solidFill>
           <a:ln>
             <a:solidFill>
-              <a:srgbClr val="1A1A2E"/>
+              <a:srgbClr val="000000"/>
             </a:solidFill>
           </a:ln>
         </p:spPr>
@@ -4691,11 +4691,11 @@
             <a:avLst/>
           </a:prstGeom>
           <a:solidFill>
-            <a:srgbClr val="101218"/>
+            <a:srgbClr val="D7F1F3"/>
           </a:solidFill>
           <a:ln>
             <a:solidFill>
-              <a:srgbClr val="1E222A"/>
+              <a:srgbClr val="DCE6EA"/>
             </a:solidFill>
           </a:ln>
         </p:spPr>
@@ -4736,11 +4736,11 @@
             <a:avLst/>
           </a:prstGeom>
           <a:solidFill>
-            <a:srgbClr val="0E1016"/>
+            <a:srgbClr val="EEF8F9"/>
           </a:solidFill>
           <a:ln>
             <a:solidFill>
-              <a:srgbClr val="1E222A"/>
+              <a:srgbClr val="DCE6EA"/>
             </a:solidFill>
           </a:ln>
         </p:spPr>
@@ -4781,11 +4781,11 @@
             <a:avLst/>
           </a:prstGeom>
           <a:solidFill>
-            <a:srgbClr val="14130E"/>
+            <a:srgbClr val="FFF0C7"/>
           </a:solidFill>
           <a:ln>
             <a:solidFill>
-              <a:srgbClr val="2A281E"/>
+              <a:srgbClr val="ECE1B7"/>
             </a:solidFill>
           </a:ln>
         </p:spPr>
@@ -4826,11 +4826,11 @@
             <a:avLst/>
           </a:prstGeom>
           <a:solidFill>
-            <a:srgbClr val="12141A"/>
+            <a:srgbClr val="FFFFFF"/>
           </a:solidFill>
           <a:ln>
             <a:solidFill>
-              <a:srgbClr val="1E222A"/>
+              <a:srgbClr val="D8DDE5"/>
             </a:solidFill>
           </a:ln>
         </p:spPr>
@@ -4882,7 +4882,7 @@
             <a:r>
               <a:rPr sz="1500" b="1">
                 <a:solidFill>
-                  <a:srgbClr val="E8E8ED"/>
+                  <a:srgbClr val="1F2937"/>
                 </a:solidFill>
                 <a:latin typeface="Aptos"/>
               </a:rPr>
@@ -4917,7 +4917,7 @@
             <a:r>
               <a:rPr sz="1060" b="0">
                 <a:solidFill>
-                  <a:srgbClr val="B0B0C0"/>
+                  <a:srgbClr val="415062"/>
                 </a:solidFill>
                 <a:latin typeface="Aptos"/>
               </a:rPr>
@@ -4952,7 +4952,7 @@
             <a:r>
               <a:rPr sz="1220" b="1">
                 <a:solidFill>
-                  <a:srgbClr val="E8E8ED"/>
+                  <a:srgbClr val="1F2937"/>
                 </a:solidFill>
                 <a:latin typeface="Aptos"/>
               </a:rPr>
@@ -4995,11 +4995,6 @@
               </a:defRPr>
             </a:pPr>
             <a:r>
-              <a:rPr>
-                <a:solidFill>
-                  <a:srgbClr val="B0B0C0"/>
-                </a:solidFill>
-              </a:rPr>
               <a:t>JefAI Product Lead: took ownership of product leadership for Jefferies' AI platform after my initial engagement was extended into a full-year contract, demonstrating trusted client ownership beyond an intake/proof-of-concept role.</a:t>
             </a:r>
           </a:p>
@@ -5016,11 +5011,6 @@
               </a:defRPr>
             </a:pPr>
             <a:r>
-              <a:rPr>
-                <a:solidFill>
-                  <a:srgbClr val="B0B0C0"/>
-                </a:solidFill>
-              </a:rPr>
               <a:t>Roadmap and governance: created Jefferies' first AI product roadmap and designed the JefAI programme dashboard to give stakeholders visibility into roadmap progress, risks, status and KPIs.</a:t>
             </a:r>
           </a:p>
@@ -5037,11 +5027,6 @@
               </a:defRPr>
             </a:pPr>
             <a:r>
-              <a:rPr>
-                <a:solidFill>
-                  <a:srgbClr val="B0B0C0"/>
-                </a:solidFill>
-              </a:rPr>
               <a:t>Operating at scale: manage product across an engineering organisation of approximately 26 people and coordinate with MP/ED/C-level stakeholders on priorities, delivery sequencing and platform evolution.</a:t>
             </a:r>
           </a:p>
@@ -5058,11 +5043,6 @@
               </a:defRPr>
             </a:pPr>
             <a:r>
-              <a:rPr>
-                <a:solidFill>
-                  <a:srgbClr val="B0B0C0"/>
-                </a:solidFill>
-              </a:rPr>
               <a:t>Programme leadership: helped move Jefferies from fragmented AI intake activity into a more structured, sustained product programme with repeatable roadmap execution and clear stakeholder alignment.</a:t>
             </a:r>
           </a:p>
@@ -5079,11 +5059,6 @@
               </a:defRPr>
             </a:pPr>
             <a:r>
-              <a:rPr>
-                <a:solidFill>
-                  <a:srgbClr val="B0B0C0"/>
-                </a:solidFill>
-              </a:rPr>
               <a:t>Leadership trajectory: the next step is to become the AI lead across the broader Jefferies AI programme, overseeing multiple AI workstreams given that I have helped build this from the ground up, work directly with C-level stakeholders and built strong relationships across divisions.</a:t>
             </a:r>
           </a:p>
@@ -5100,11 +5075,6 @@
               </a:defRPr>
             </a:pPr>
             <a:r>
-              <a:rPr>
-                <a:solidFill>
-                  <a:srgbClr val="B0B0C0"/>
-                </a:solidFill>
-              </a:rPr>
               <a:t>Trusted delivery leadership: acted as the pointed deputy for an MP-level AI programme delivery lead and helped run the team through roadmap communication, stakeholder coordination and delivery structure.</a:t>
             </a:r>
           </a:p>
@@ -5121,11 +5091,6 @@
               </a:defRPr>
             </a:pPr>
             <a:r>
-              <a:rPr>
-                <a:solidFill>
-                  <a:srgbClr val="B0B0C0"/>
-                </a:solidFill>
-              </a:rPr>
               <a:t>Executive visibility: became a regular speaker on the Jefferies AI Ambassadors call, presenting new solutions and sharing AI insight with a broader business audience.</a:t>
             </a:r>
           </a:p>
@@ -5157,7 +5122,7 @@
             <a:r>
               <a:rPr sz="1220" b="1">
                 <a:solidFill>
-                  <a:srgbClr val="E8E8ED"/>
+                  <a:srgbClr val="1F2937"/>
                 </a:solidFill>
                 <a:latin typeface="Aptos"/>
               </a:rPr>
@@ -5200,11 +5165,6 @@
               </a:defRPr>
             </a:pPr>
             <a:r>
-              <a:rPr>
-                <a:solidFill>
-                  <a:srgbClr val="B0B0C0"/>
-                </a:solidFill>
-              </a:rPr>
               <a:t>I have learned how to operate as both product owner and programme lead in a complex client environment, balancing senior stakeholder management, execution discipline and roadmap design.</a:t>
             </a:r>
           </a:p>
@@ -5221,11 +5181,6 @@
               </a:defRPr>
             </a:pPr>
             <a:r>
-              <a:rPr>
-                <a:solidFill>
-                  <a:srgbClr val="B0B0C0"/>
-                </a:solidFill>
-              </a:rPr>
               <a:t>At the next level, I would continue expanding JefAI from a roadmap-led platform into a broader enterprise AI product ecosystem, scaling adoption, solution maturity and commercial value for both Jefferies and Capco.</a:t>
             </a:r>
           </a:p>
@@ -5257,7 +5212,7 @@
             <a:r>
               <a:rPr sz="1400" b="1">
                 <a:solidFill>
-                  <a:srgbClr val="E8E8ED"/>
+                  <a:srgbClr val="1F2937"/>
                 </a:solidFill>
                 <a:latin typeface="Aptos"/>
               </a:rPr>
@@ -5300,11 +5255,6 @@
               </a:defRPr>
             </a:pPr>
             <a:r>
-              <a:rPr>
-                <a:solidFill>
-                  <a:srgbClr val="B0B0C0"/>
-                </a:solidFill>
-              </a:rPr>
               <a:t>I helped convert my Jefferies work from an initial AI intake/proof phase into a year-long product engagement, directly supporting continued revenue on the account.</a:t>
             </a:r>
           </a:p>
@@ -5321,11 +5271,6 @@
               </a:defRPr>
             </a:pPr>
             <a:r>
-              <a:rPr>
-                <a:solidFill>
-                  <a:srgbClr val="B0B0C0"/>
-                </a:solidFill>
-              </a:rPr>
               <a:t>By leading the JefAI roadmap and enterprise product direction, I am helping create scope for additional AI platform work and future solution expansion at Jefferies.</a:t>
             </a:r>
           </a:p>
@@ -5342,11 +5287,6 @@
               </a:defRPr>
             </a:pPr>
             <a:r>
-              <a:rPr>
-                <a:solidFill>
-                  <a:srgbClr val="B0B0C0"/>
-                </a:solidFill>
-              </a:rPr>
               <a:t>I contribute commercially by turning AI demos, product assets and market-facing storytelling into materials that can support pursuits, stakeholder buy-in and downstream sales opportunities.</a:t>
             </a:r>
           </a:p>
@@ -5363,11 +5303,6 @@
               </a:defRPr>
             </a:pPr>
             <a:r>
-              <a:rPr>
-                <a:solidFill>
-                  <a:srgbClr val="B0B0C0"/>
-                </a:solidFill>
-              </a:rPr>
               <a:t>External speaking and thought leadership increase Capco's visibility in GenAI and can help generate future client conversations, brand credibility and pipeline opportunities.</a:t>
             </a:r>
           </a:p>
@@ -5399,7 +5334,7 @@
             <a:r>
               <a:rPr sz="1030" b="0">
                 <a:solidFill>
-                  <a:srgbClr val="B0B0C0"/>
+                  <a:srgbClr val="415062"/>
                 </a:solidFill>
                 <a:latin typeface="Aptos"/>
               </a:rPr>
@@ -5434,7 +5369,7 @@
             <a:r>
               <a:rPr sz="1250" b="1">
                 <a:solidFill>
-                  <a:srgbClr val="E8E8ED"/>
+                  <a:srgbClr val="1F2937"/>
                 </a:solidFill>
                 <a:latin typeface="Aptos"/>
               </a:rPr>
@@ -5469,7 +5404,7 @@
             <a:r>
               <a:rPr sz="990" b="0">
                 <a:solidFill>
-                  <a:srgbClr val="B0B0C0"/>
+                  <a:srgbClr val="415062"/>
                 </a:solidFill>
                 <a:latin typeface="Aptos"/>
               </a:rPr>
@@ -5505,7 +5440,7 @@
             <a:r>
               <a:rPr sz="1050" b="0">
                 <a:solidFill>
-                  <a:srgbClr val="B0B0C0"/>
+                  <a:srgbClr val="1F2937"/>
                 </a:solidFill>
                 <a:latin typeface="Aptos"/>
               </a:rPr>
@@ -5529,11 +5464,11 @@
             <a:avLst/>
           </a:prstGeom>
           <a:solidFill>
-            <a:srgbClr val="161B22"/>
+            <a:srgbClr val="FFFFFF"/>
           </a:solidFill>
           <a:ln>
             <a:solidFill>
-              <a:srgbClr val="2A2E36"/>
+              <a:srgbClr val="D8DDE5"/>
             </a:solidFill>
           </a:ln>
         </p:spPr>
@@ -5585,7 +5520,7 @@
             <a:r>
               <a:rPr sz="1050" b="0">
                 <a:solidFill>
-                  <a:srgbClr val="B0B0C0"/>
+                  <a:srgbClr val="1F2937"/>
                 </a:solidFill>
                 <a:latin typeface="Aptos"/>
               </a:rPr>
@@ -5609,11 +5544,11 @@
             <a:avLst/>
           </a:prstGeom>
           <a:solidFill>
-            <a:srgbClr val="161B22"/>
+            <a:srgbClr val="FFFFFF"/>
           </a:solidFill>
           <a:ln>
             <a:solidFill>
-              <a:srgbClr val="2A2E36"/>
+              <a:srgbClr val="D8DDE5"/>
             </a:solidFill>
           </a:ln>
         </p:spPr>
@@ -5665,7 +5600,7 @@
             <a:r>
               <a:rPr sz="1050" b="0">
                 <a:solidFill>
-                  <a:srgbClr val="B0B0C0"/>
+                  <a:srgbClr val="1F2937"/>
                 </a:solidFill>
                 <a:latin typeface="Aptos"/>
               </a:rPr>
@@ -5689,11 +5624,11 @@
             <a:avLst/>
           </a:prstGeom>
           <a:solidFill>
-            <a:srgbClr val="161B22"/>
+            <a:srgbClr val="FFFFFF"/>
           </a:solidFill>
           <a:ln>
             <a:solidFill>
-              <a:srgbClr val="2A2E36"/>
+              <a:srgbClr val="D8DDE5"/>
             </a:solidFill>
           </a:ln>
         </p:spPr>
@@ -5745,7 +5680,7 @@
             <a:r>
               <a:rPr sz="1050" b="0">
                 <a:solidFill>
-                  <a:srgbClr val="B0B0C0"/>
+                  <a:srgbClr val="1F2937"/>
                 </a:solidFill>
                 <a:latin typeface="Aptos"/>
               </a:rPr>
@@ -5769,11 +5704,11 @@
             <a:avLst/>
           </a:prstGeom>
           <a:solidFill>
-            <a:srgbClr val="161B22"/>
+            <a:srgbClr val="FFFFFF"/>
           </a:solidFill>
           <a:ln>
             <a:solidFill>
-              <a:srgbClr val="2A2E36"/>
+              <a:srgbClr val="D8DDE5"/>
             </a:solidFill>
           </a:ln>
         </p:spPr>
@@ -5825,7 +5760,7 @@
             <a:r>
               <a:rPr sz="1050" b="0">
                 <a:solidFill>
-                  <a:srgbClr val="B0B0C0"/>
+                  <a:srgbClr val="1F2937"/>
                 </a:solidFill>
                 <a:latin typeface="Aptos"/>
               </a:rPr>
@@ -5849,11 +5784,11 @@
             <a:avLst/>
           </a:prstGeom>
           <a:solidFill>
-            <a:srgbClr val="161B22"/>
+            <a:srgbClr val="FFFFFF"/>
           </a:solidFill>
           <a:ln>
             <a:solidFill>
-              <a:srgbClr val="2A2E36"/>
+              <a:srgbClr val="D8DDE5"/>
             </a:solidFill>
           </a:ln>
         </p:spPr>
@@ -5905,7 +5840,7 @@
             <a:r>
               <a:rPr sz="1050" b="0">
                 <a:solidFill>
-                  <a:srgbClr val="B0B0C0"/>
+                  <a:srgbClr val="1F2937"/>
                 </a:solidFill>
                 <a:latin typeface="Aptos"/>
               </a:rPr>
@@ -5929,11 +5864,11 @@
             <a:avLst/>
           </a:prstGeom>
           <a:solidFill>
-            <a:srgbClr val="161B22"/>
+            <a:srgbClr val="FFFFFF"/>
           </a:solidFill>
           <a:ln>
             <a:solidFill>
-              <a:srgbClr val="2A2E36"/>
+              <a:srgbClr val="D8DDE5"/>
             </a:solidFill>
           </a:ln>
         </p:spPr>
@@ -5985,7 +5920,7 @@
             <a:r>
               <a:rPr sz="780" b="0">
                 <a:solidFill>
-                  <a:srgbClr val="5A5A6E"/>
+                  <a:srgbClr val="9CA3AF"/>
                 </a:solidFill>
                 <a:latin typeface="Aptos"/>
               </a:rPr>
@@ -6020,7 +5955,7 @@
             <a:r>
               <a:rPr sz="1000" b="0">
                 <a:solidFill>
-                  <a:srgbClr val="5A5A6E"/>
+                  <a:srgbClr val="9CA3AF"/>
                 </a:solidFill>
                 <a:latin typeface="Aptos"/>
               </a:rPr>
@@ -6054,7 +5989,7 @@
             <a:r>
               <a:rPr sz="900">
                 <a:solidFill>
-                  <a:srgbClr val="8B8B9E"/>
+                  <a:srgbClr val="6B7280"/>
                 </a:solidFill>
               </a:rPr>
               <a:t>View full interactive portfolio →  </a:t>
@@ -6062,7 +5997,7 @@
             <a:r>
               <a:rPr sz="900" u="sng">
                 <a:solidFill>
-                  <a:srgbClr val="00BFA6"/>
+                  <a:srgbClr val="009682"/>
                 </a:solidFill>
                 <a:hlinkClick r:id="rId2"/>
               </a:rPr>

</xml_diff>

<commit_message>
Update PPTX forward planning content to match website's cross-domain message
- Learning and forward planning: reflects how Jefferies + AI Lab experience
  builds cross-domain, cross-account commercial visibility
- Go-forward plan: broader focus on supporting pursuits across domains/accounts,
  not just Jefferies-specific

https://claude.ai/code/session_019RPF8j4FKwWWZrkstQbaTn
</commit_message>
<xml_diff>
--- a/Jessie_Wang_Promotion_Case_v2.pptx
+++ b/Jessie_Wang_Promotion_Case_v2.pptx
@@ -5165,23 +5165,17 @@
               </a:defRPr>
             </a:pPr>
             <a:r>
-              <a:t>I have learned how to operate as both product owner and programme lead in a complex client environment, balancing senior stakeholder management, execution discipline and roadmap design.</a:t>
+              <a:t>The hands-on experience of building and leading Jefferies’ AI platform — from intake to enterprise roadmap — combined with running the Global AI Lab and Demo Day, has built deep expertise in AI product strategy, stakeholder management, and delivery at scale that transfers to any client and any domain.</a:t>
             </a:r>
           </a:p>
           <a:p>
             <a:pPr>
-              <a:spcAft>
-                <a:spcPts val="200"/>
-              </a:spcAft>
-              <a:defRPr sz="969">
-                <a:solidFill>
-                  <a:srgbClr val="39485A"/>
-                </a:solidFill>
-                <a:latin typeface="Aptos"/>
-              </a:defRPr>
+              <a:spcBef>
+                <a:spcPts val="600"/>
+              </a:spcBef>
             </a:pPr>
             <a:r>
-              <a:t>At the next level, I would continue expanding JefAI from a roadmap-led platform into a broader enterprise AI product ecosystem, scaling adoption, solution maturity and commercial value for both Jefferies and Capco.</a:t>
+              <a:t>This cross-domain and cross-account visibility — knowing what solutions exist, which teams can deliver them, and where commercial opportunities lie — positions me to support pursuits, RFPs, and demos across accounts, turning internal AI knowledge into repeatable commercial value for Capco.</a:t>
             </a:r>
           </a:p>
         </p:txBody>
@@ -5332,13 +5326,12 @@
           <a:p>
             <a:pPr algn="l"/>
             <a:r>
-              <a:rPr sz="1030" b="0">
+              <a:rPr sz="1030">
                 <a:solidFill>
                   <a:srgbClr val="415062"/>
                 </a:solidFill>
-                <a:latin typeface="Aptos"/>
               </a:rPr>
-              <a:t>Go-forward pipeline and plan: deepen the Jefferies platform opportunity, identify adjacent enterprise AI solution opportunities that can expand account revenue, and continue using external visibility, demos and reusable AI assets to support new commercial conversations for Capco.</a:t>
+              <a:t>Go-forward plan: leverage deep Jefferies delivery experience and AI Lab leadership to support commercial opportunities across domains and accounts. Continue building reusable AI assets, demos, and thought leadership that accelerate pursuits firm-wide — while expanding the Jefferies platform into a broader enterprise AI ecosystem.</a:t>
             </a:r>
           </a:p>
         </p:txBody>

</xml_diff>